<commit_message>
MQTT-Live update and fixes
</commit_message>
<xml_diff>
--- a/folien/10-mqtt-live.pptx
+++ b/folien/10-mqtt-live.pptx
@@ -5669,7 +5669,7 @@
                 <a:ea typeface="Arial" pitchFamily="34" charset="-122"/>
                 <a:cs typeface="Arial" pitchFamily="34" charset="-120"/>
               </a:rPr>
-              <a:t>Ein eigener Sensor im Container: eure Ofentemperatur live auf der Tafel</a:t>
+              <a:t>Eigener Sensor im Container, danach Bonus: QoS live, Platzhalter +, Retain löschen</a:t>
             </a:r>
             <a:endParaRPr lang="en-US" sz="1050" dirty="0"/>
           </a:p>
@@ -11122,8 +11122,8 @@
         </p:blipFill>
         <p:spPr>
           <a:xfrm>
-            <a:off x="566928" y="1353312"/>
-            <a:ext cx="8010144" cy="2651760"/>
+            <a:off x="566928" y="1316736"/>
+            <a:ext cx="8010144" cy="2889504"/>
           </a:xfrm>
           <a:prstGeom prst="rect">
             <a:avLst/>
@@ -11138,7 +11138,7 @@
         </p:nvSpPr>
         <p:spPr>
           <a:xfrm>
-            <a:off x="566928" y="4178808"/>
+            <a:off x="566928" y="4288536"/>
             <a:ext cx="32004" cy="256032"/>
           </a:xfrm>
           <a:prstGeom prst="rect">
@@ -11158,7 +11158,7 @@
         </p:nvSpPr>
         <p:spPr>
           <a:xfrm>
-            <a:off x="749808" y="4133088"/>
+            <a:off x="749808" y="4242816"/>
             <a:ext cx="7827264" cy="402336"/>
           </a:xfrm>
           <a:prstGeom prst="rect">
@@ -11183,7 +11183,7 @@
                 <a:ea typeface="Arial" pitchFamily="34" charset="-122"/>
                 <a:cs typeface="Arial" pitchFamily="34" charset="-120"/>
               </a:rPr>
-              <a:t>Merksatz: 0 höchstens einmal, 1 mindestens einmal, 2 genau einmal. Mehr Sicherheit kostet mehr Pakete.</a:t>
+              <a:t>Merksatz: 0 höchstens einmal, 1 mindestens einmal, 2 genau einmal.</a:t>
             </a:r>
             <a:endParaRPr lang="en-US" sz="1200" dirty="0"/>
           </a:p>

</xml_diff>